<commit_message>
fix: Add resilient database fallback so portal never goes down
</commit_message>
<xml_diff>
--- a/Team_Gantavya.pptx
+++ b/Team_Gantavya.pptx
@@ -261,7 +261,7 @@
             <a:fld id="{C4D5ADD5-2BBC-4A94-8F86-D9013941F742}" type="datetimeFigureOut">
               <a:rPr lang="en-US"/>
               <a:pPr/>
-              <a:t>8/30/26</a:t>
+              <a:t>9/2/26</a:t>
             </a:fld>
             <a:endParaRPr lang="en-US"/>
           </a:p>
@@ -1602,7 +1602,7 @@
           <a:p>
             <a:fld id="{E60792E3-D524-454C-8AFD-A91972900BCB}" type="datetime1">
               <a:rPr lang="en-US" smtClean="0"/>
-              <a:t>8/30/26</a:t>
+              <a:t>9/2/26</a:t>
             </a:fld>
             <a:endParaRPr lang="en-US"/>
           </a:p>
@@ -1784,7 +1784,7 @@
           <a:p>
             <a:fld id="{053C3A68-6922-42D3-8905-ECC2D82A3469}" type="datetime1">
               <a:rPr lang="en-US" smtClean="0"/>
-              <a:t>8/30/26</a:t>
+              <a:t>9/2/26</a:t>
             </a:fld>
             <a:endParaRPr lang="en-US"/>
           </a:p>
@@ -1976,7 +1976,7 @@
           <a:p>
             <a:fld id="{CB69E9F4-7604-4950-A8B2-8ACDEDB1506E}" type="datetime1">
               <a:rPr lang="en-US" smtClean="0"/>
-              <a:t>8/30/26</a:t>
+              <a:t>9/2/26</a:t>
             </a:fld>
             <a:endParaRPr lang="en-US"/>
           </a:p>
@@ -2158,7 +2158,7 @@
           <a:p>
             <a:fld id="{708B7524-32A2-4C20-A58C-BC3BAA1042FC}" type="datetime1">
               <a:rPr lang="en-US" smtClean="0"/>
-              <a:t>8/30/26</a:t>
+              <a:t>9/2/26</a:t>
             </a:fld>
             <a:endParaRPr lang="en-US"/>
           </a:p>
@@ -2417,7 +2417,7 @@
           <a:p>
             <a:fld id="{1E994447-D6B2-43BB-A877-57F1A267B999}" type="datetime1">
               <a:rPr lang="en-US" smtClean="0"/>
-              <a:t>8/30/26</a:t>
+              <a:t>9/2/26</a:t>
             </a:fld>
             <a:endParaRPr lang="en-US"/>
           </a:p>
@@ -2716,7 +2716,7 @@
           <a:p>
             <a:fld id="{68920E16-BD35-483C-AA6B-346FC7E46DEA}" type="datetime1">
               <a:rPr lang="en-US" smtClean="0"/>
-              <a:t>8/30/26</a:t>
+              <a:t>9/2/26</a:t>
             </a:fld>
             <a:endParaRPr lang="en-US"/>
           </a:p>
@@ -3149,7 +3149,7 @@
           <a:p>
             <a:fld id="{2FEAC6F8-5103-4FC0-A69E-5C6AE6469DA8}" type="datetime1">
               <a:rPr lang="en-US" smtClean="0"/>
-              <a:t>8/30/26</a:t>
+              <a:t>9/2/26</a:t>
             </a:fld>
             <a:endParaRPr lang="en-US"/>
           </a:p>
@@ -3280,7 +3280,7 @@
           <a:p>
             <a:fld id="{C60C6921-0627-4C8F-83D5-0CF936D2FFDD}" type="datetime1">
               <a:rPr lang="en-US" smtClean="0"/>
-              <a:t>8/30/26</a:t>
+              <a:t>9/2/26</a:t>
             </a:fld>
             <a:endParaRPr lang="en-US"/>
           </a:p>
@@ -3389,7 +3389,7 @@
           <a:p>
             <a:fld id="{2FF08AD7-8103-40F8-983C-E2BA6BB9CBE0}" type="datetime1">
               <a:rPr lang="en-US" smtClean="0"/>
-              <a:t>8/30/26</a:t>
+              <a:t>9/2/26</a:t>
             </a:fld>
             <a:endParaRPr lang="en-US"/>
           </a:p>
@@ -3678,7 +3678,7 @@
           <a:p>
             <a:fld id="{DF8C06B4-9380-4A4D-AF49-A3596E17DAF5}" type="datetime1">
               <a:rPr lang="en-US" smtClean="0"/>
-              <a:t>8/30/26</a:t>
+              <a:t>9/2/26</a:t>
             </a:fld>
             <a:endParaRPr lang="en-US"/>
           </a:p>
@@ -3947,7 +3947,7 @@
           <a:p>
             <a:fld id="{EF7FDEF1-C582-4E22-9E77-D68326471F28}" type="datetime1">
               <a:rPr lang="en-US" smtClean="0"/>
-              <a:t>8/30/26</a:t>
+              <a:t>9/2/26</a:t>
             </a:fld>
             <a:endParaRPr lang="en-US"/>
           </a:p>
@@ -4190,7 +4190,7 @@
           <a:p>
             <a:fld id="{780A9602-A9A9-453F-AEF1-37B5837E02CD}" type="datetime1">
               <a:rPr lang="en-US" smtClean="0"/>
-              <a:t>8/30/26</a:t>
+              <a:t>9/2/26</a:t>
             </a:fld>
             <a:endParaRPr lang="en-US"/>
           </a:p>
@@ -5850,6 +5850,42 @@
             </a:r>
           </a:p>
           <a:p>
+            <a:pPr marL="285750" indent="-285750">
+              <a:lnSpc>
+                <a:spcPct val="125000"/>
+              </a:lnSpc>
+              <a:spcBef>
+                <a:spcPts val="1200"/>
+              </a:spcBef>
+              <a:buFont typeface="Arial"/>
+              <a:buChar char="•"/>
+            </a:pPr>
+            <a:r>
+              <a:rPr lang="en-US" sz="2000" b="1" dirty="0">
+                <a:solidFill>
+                  <a:srgbClr val="0F172A"/>
+                </a:solidFill>
+                <a:latin typeface="Arial"/>
+              </a:rPr>
+              <a:t>Team ID – </a:t>
+            </a:r>
+            <a:r>
+              <a:rPr lang="en-US" sz="2000" b="1" dirty="0">
+                <a:solidFill>
+                  <a:srgbClr val="047857"/>
+                </a:solidFill>
+                <a:latin typeface="Arial"/>
+              </a:rPr>
+              <a:t>IH03</a:t>
+            </a:r>
+            <a:endParaRPr lang="en-US" sz="2000" b="0" dirty="0">
+              <a:solidFill>
+                <a:srgbClr val="1E293B"/>
+              </a:solidFill>
+              <a:latin typeface="Arial"/>
+            </a:endParaRPr>
+          </a:p>
+          <a:p>
             <a:pPr marL="285750" indent="-285750" algn="l">
               <a:lnSpc>
                 <a:spcPct val="125000"/>
@@ -5861,22 +5897,13 @@
               <a:buChar char="•"/>
             </a:pPr>
             <a:r>
-              <a:rPr lang="en-US" sz="2000" b="1">
+              <a:rPr lang="en-US" sz="2000" b="1" dirty="0">
                 <a:solidFill>
                   <a:srgbClr val="0F172A"/>
                 </a:solidFill>
                 <a:latin typeface="Arial"/>
               </a:rPr>
-              <a:t>Team </a:t>
-            </a:r>
-            <a:r>
-              <a:rPr lang="en-US" sz="2000" b="1" dirty="0">
-                <a:solidFill>
-                  <a:srgbClr val="0F172A"/>
-                </a:solidFill>
-                <a:latin typeface="Arial"/>
-              </a:rPr>
-              <a:t>Name  – </a:t>
+              <a:t>Team Name  – </a:t>
             </a:r>
             <a:r>
               <a:rPr lang="en-US" sz="2000" b="1" dirty="0">

</xml_diff>